<commit_message>
Update the Short Reads gateway hero and slide decks
- Gateway page picks up the new inline hero photograph and tighter top
  padding from the updated package; site bar, links and meta are kept.
- Gateway og:image and twitter:image now point at the new
  gateway-hero-2560x1080.png, which is served from assets/companions/.
- The six pieces' decks (PDF and PPTX) are swapped for versions with new
  cover slides. The gateway decks were unchanged in the package.

Co-Authored-By: Claude Opus 5.5 <noreply@anthropic.com>
</commit_message>
<xml_diff>
--- a/assets/companions/how-would-you-know.pptx
+++ b/assets/companions/how-would-you-know.pptx
@@ -2946,150 +2946,261 @@
           <a:chExt cx="0" cy="0"/>
         </a:xfrm>
       </p:grpSpPr>
-      <p:sp>
-        <p:nvSpPr>
-          <p:cNvPr id="2" name="Text 0"/>
-          <p:cNvSpPr txBox="1"/>
-          <p:nvPr/>
-        </p:nvSpPr>
-        <p:spPr>
-          <a:xfrm>
-            <a:off x="621792" y="658368"/>
-            <a:ext cx="6400800" cy="310896"/>
-          </a:xfrm>
-          <a:prstGeom prst="rect">
-            <a:avLst/>
-          </a:prstGeom>
-          <a:noFill/>
-          <a:ln/>
-        </p:spPr>
-        <p:txBody>
-          <a:bodyPr wrap="square" lIns="0" tIns="0" rIns="0" bIns="0" rtlCol="0" anchor="ctr"/>
-          <a:lstStyle/>
-          <a:p>
-            <a:pPr indent="0" marL="0">
-              <a:buNone/>
-            </a:pPr>
-            <a:r>
-              <a:rPr lang="en-US" sz="1200" b="1" spc="300" kern="0" dirty="0">
-                <a:solidFill>
-                  <a:srgbClr val="F47920"/>
-                </a:solidFill>
-                <a:latin typeface="Trebuchet MS" pitchFamily="34" charset="0"/>
-                <a:ea typeface="Trebuchet MS" pitchFamily="34" charset="-122"/>
-                <a:cs typeface="Trebuchet MS" pitchFamily="34" charset="-120"/>
-              </a:rPr>
-              <a:t>ARCHITECTURE &amp; ATTENTION</a:t>
-            </a:r>
-            <a:endParaRPr lang="en-US" sz="1200" dirty="0"/>
-          </a:p>
-        </p:txBody>
-      </p:sp>
-      <p:sp>
-        <p:nvSpPr>
-          <p:cNvPr id="3" name="Text 1"/>
-          <p:cNvSpPr txBox="1"/>
-          <p:nvPr/>
-        </p:nvSpPr>
-        <p:spPr>
-          <a:xfrm>
-            <a:off x="621792" y="1737360"/>
-            <a:ext cx="6583680" cy="2011680"/>
-          </a:xfrm>
-          <a:prstGeom prst="rect">
-            <a:avLst/>
-          </a:prstGeom>
-          <a:noFill/>
-          <a:ln/>
-        </p:spPr>
-        <p:txBody>
-          <a:bodyPr wrap="square" lIns="0" tIns="0" rIns="0" bIns="0" rtlCol="0" anchor="t"/>
-          <a:lstStyle/>
-          <a:p>
-            <a:pPr indent="0" marL="0">
-              <a:buNone/>
-            </a:pPr>
-            <a:r>
-              <a:rPr lang="en-US" sz="4600" b="1" dirty="0">
-                <a:solidFill>
-                  <a:srgbClr val="FFFFFF"/>
-                </a:solidFill>
-                <a:latin typeface="Georgia" pitchFamily="34" charset="0"/>
-                <a:ea typeface="Georgia" pitchFamily="34" charset="-122"/>
-                <a:cs typeface="Georgia" pitchFamily="34" charset="-120"/>
-              </a:rPr>
-              <a:t>How Would You Know?</a:t>
-            </a:r>
-            <a:endParaRPr lang="en-US" sz="4600" dirty="0"/>
-          </a:p>
-        </p:txBody>
-      </p:sp>
-      <p:sp>
-        <p:nvSpPr>
-          <p:cNvPr id="4" name="Text 2"/>
-          <p:cNvSpPr txBox="1"/>
-          <p:nvPr/>
-        </p:nvSpPr>
-        <p:spPr>
-          <a:xfrm>
-            <a:off x="621792" y="3886200"/>
-            <a:ext cx="6949440" cy="1645920"/>
-          </a:xfrm>
-          <a:prstGeom prst="rect">
-            <a:avLst/>
-          </a:prstGeom>
-          <a:noFill/>
-          <a:ln/>
-        </p:spPr>
-        <p:txBody>
-          <a:bodyPr wrap="square" lIns="0" tIns="0" rIns="0" bIns="0" rtlCol="0" anchor="t"/>
-          <a:lstStyle/>
-          <a:p>
-            <a:pPr indent="0" marL="0">
-              <a:lnSpc>
-                <a:spcPct val="130000"/>
-              </a:lnSpc>
-              <a:buNone/>
-            </a:pPr>
-            <a:r>
-              <a:rPr lang="en-US" sz="1700" dirty="0">
-                <a:solidFill>
-                  <a:srgbClr val="B9C4D0"/>
-                </a:solidFill>
-                <a:latin typeface="Trebuchet MS" pitchFamily="34" charset="0"/>
-                <a:ea typeface="Trebuchet MS" pitchFamily="34" charset="-122"/>
-                <a:cs typeface="Trebuchet MS" pitchFamily="34" charset="-120"/>
-              </a:rPr>
-              <a:t>Two people review the same document and reach the same conclusion. One of them thought about it. The other agreed with it. No inspection anybody currently runs can tell them apart.</a:t>
-            </a:r>
-            <a:endParaRPr lang="en-US" sz="1700" dirty="0"/>
-          </a:p>
-        </p:txBody>
-      </p:sp>
       <p:pic>
         <p:nvPicPr>
-          <p:cNvPr id="5" name="brand-mark" descr="/tmp/claude-0/-home-claude/840a28d2-2874-58f2-bea9-3fe61a55262a/scratchpad/govdeck/logo.png">    </p:cNvPr>
+          <p:cNvPr id="7" name="Picture 6" descr="cover_04.jpg"/>
           <p:cNvPicPr>
             <a:picLocks noChangeAspect="1"/>
           </p:cNvPicPr>
           <p:nvPr/>
         </p:nvPicPr>
         <p:blipFill>
-          <a:blip r:embed="rId1"/>
+          <a:blip r:embed="rId4"/>
           <a:stretch>
             <a:fillRect/>
           </a:stretch>
         </p:blipFill>
         <p:spPr>
           <a:xfrm>
-            <a:off x="8641080" y="1920240"/>
-            <a:ext cx="2926080" cy="2926080"/>
+            <a:off x="-18288" y="-18288"/>
+            <a:ext cx="12228545" cy="6894576"/>
           </a:xfrm>
           <a:prstGeom prst="rect">
             <a:avLst/>
           </a:prstGeom>
         </p:spPr>
       </p:pic>
+      <p:sp>
+        <p:nvSpPr>
+          <p:cNvPr id="8" name="Rectangle 7"/>
+          <p:cNvSpPr/>
+          <p:nvPr/>
+        </p:nvSpPr>
+        <p:spPr>
+          <a:xfrm>
+            <a:off x="0" y="0"/>
+            <a:ext cx="12191969" cy="6858000"/>
+          </a:xfrm>
+          <a:prstGeom prst="rect">
+            <a:avLst/>
+          </a:prstGeom>
+          <a:solidFill>
+            <a:srgbClr val="000000">
+              <a:alpha val="20000"/>
+            </a:srgbClr>
+          </a:solidFill>
+          <a:ln>
+            <a:noFill/>
+          </a:ln>
+          <a:effectLst/>
+        </p:spPr>
+        <p:style>
+          <a:lnRef idx="1">
+            <a:schemeClr val="accent1"/>
+          </a:lnRef>
+          <a:fillRef idx="3">
+            <a:schemeClr val="accent1"/>
+          </a:fillRef>
+          <a:effectRef idx="2">
+            <a:schemeClr val="accent1"/>
+          </a:effectRef>
+          <a:fontRef idx="minor">
+            <a:schemeClr val="lt1"/>
+          </a:fontRef>
+        </p:style>
+        <p:txBody>
+          <a:bodyPr rtlCol="0" anchor="ctr"/>
+          <a:lstStyle/>
+          <a:p>
+            <a:pPr algn="ctr"/>
+          </a:p>
+        </p:txBody>
+      </p:sp>
+      <p:sp>
+        <p:nvSpPr>
+          <p:cNvPr id="9" name="Rectangle 8"/>
+          <p:cNvSpPr/>
+          <p:nvPr/>
+        </p:nvSpPr>
+        <p:spPr>
+          <a:xfrm>
+            <a:off x="0" y="0"/>
+            <a:ext cx="12191969" cy="100584"/>
+          </a:xfrm>
+          <a:prstGeom prst="rect">
+            <a:avLst/>
+          </a:prstGeom>
+          <a:solidFill>
+            <a:srgbClr val="F47920"/>
+          </a:solidFill>
+          <a:ln>
+            <a:noFill/>
+          </a:ln>
+          <a:effectLst/>
+        </p:spPr>
+        <p:style>
+          <a:lnRef idx="1">
+            <a:schemeClr val="accent1"/>
+          </a:lnRef>
+          <a:fillRef idx="3">
+            <a:schemeClr val="accent1"/>
+          </a:fillRef>
+          <a:effectRef idx="2">
+            <a:schemeClr val="accent1"/>
+          </a:effectRef>
+          <a:fontRef idx="minor">
+            <a:schemeClr val="lt1"/>
+          </a:fontRef>
+        </p:style>
+        <p:txBody>
+          <a:bodyPr rtlCol="0" anchor="ctr"/>
+          <a:lstStyle/>
+          <a:p>
+            <a:pPr algn="ctr"/>
+          </a:p>
+        </p:txBody>
+      </p:sp>
+      <p:sp>
+        <p:nvSpPr>
+          <p:cNvPr id="2" name="Text 0"/>
+          <p:cNvSpPr txBox="1"/>
+          <p:nvPr/>
+        </p:nvSpPr>
+        <p:spPr>
+          <a:xfrm>
+            <a:off x="621792" y="658368"/>
+            <a:ext cx="6400800" cy="310896"/>
+          </a:xfrm>
+          <a:prstGeom prst="rect">
+            <a:avLst/>
+          </a:prstGeom>
+          <a:noFill/>
+          <a:ln/>
+        </p:spPr>
+        <p:txBody>
+          <a:bodyPr wrap="square" lIns="0" tIns="0" rIns="0" bIns="0" rtlCol="0" anchor="ctr"/>
+          <a:lstStyle/>
+          <a:p>
+            <a:pPr indent="0" marL="0">
+              <a:buNone/>
+            </a:pPr>
+            <a:r>
+              <a:rPr lang="en-US" sz="1200" b="1" spc="300" kern="0" dirty="0">
+                <a:solidFill>
+                  <a:srgbClr val="FFFFFF"/>
+                </a:solidFill>
+                <a:effectLst>
+                  <a:outerShdw blurRad="165100" dist="0" dir="2700000" algn="ctr" rotWithShape="0">
+                    <a:srgbClr val="000000">
+                      <a:alpha val="96000"/>
+                    </a:srgbClr>
+                  </a:outerShdw>
+                </a:effectLst>
+                <a:latin typeface="Trebuchet MS" pitchFamily="34" charset="0"/>
+                <a:ea typeface="Trebuchet MS" pitchFamily="34" charset="-122"/>
+                <a:cs typeface="Trebuchet MS" pitchFamily="34" charset="-120"/>
+              </a:rPr>
+              <a:t>ARCHITECTURE &amp; ATTENTION</a:t>
+            </a:r>
+            <a:endParaRPr lang="en-US" sz="1200" dirty="0"/>
+          </a:p>
+        </p:txBody>
+      </p:sp>
+      <p:sp>
+        <p:nvSpPr>
+          <p:cNvPr id="3" name="Text 1"/>
+          <p:cNvSpPr txBox="1"/>
+          <p:nvPr/>
+        </p:nvSpPr>
+        <p:spPr>
+          <a:xfrm>
+            <a:off x="621792" y="1737360"/>
+            <a:ext cx="10241280" cy="2011680"/>
+          </a:xfrm>
+          <a:prstGeom prst="rect">
+            <a:avLst/>
+          </a:prstGeom>
+          <a:noFill/>
+          <a:ln/>
+        </p:spPr>
+        <p:txBody>
+          <a:bodyPr wrap="square" lIns="0" tIns="0" rIns="0" bIns="0" rtlCol="0" anchor="t"/>
+          <a:lstStyle/>
+          <a:p>
+            <a:pPr indent="0" marL="0">
+              <a:buNone/>
+            </a:pPr>
+            <a:r>
+              <a:rPr lang="en-US" sz="4600" b="1" dirty="0">
+                <a:solidFill>
+                  <a:srgbClr val="FFFFFF"/>
+                </a:solidFill>
+                <a:effectLst>
+                  <a:outerShdw blurRad="254000" dist="0" dir="2700000" algn="ctr" rotWithShape="0">
+                    <a:srgbClr val="000000">
+                      <a:alpha val="92000"/>
+                    </a:srgbClr>
+                  </a:outerShdw>
+                </a:effectLst>
+                <a:latin typeface="Georgia" pitchFamily="34" charset="0"/>
+                <a:ea typeface="Georgia" pitchFamily="34" charset="-122"/>
+                <a:cs typeface="Georgia" pitchFamily="34" charset="-120"/>
+              </a:rPr>
+              <a:t>How Would You Know?</a:t>
+            </a:r>
+            <a:endParaRPr lang="en-US" sz="4600" dirty="0"/>
+          </a:p>
+        </p:txBody>
+      </p:sp>
+      <p:sp>
+        <p:nvSpPr>
+          <p:cNvPr id="4" name="Text 2"/>
+          <p:cNvSpPr txBox="1"/>
+          <p:nvPr/>
+        </p:nvSpPr>
+        <p:spPr>
+          <a:xfrm>
+            <a:off x="621792" y="3886200"/>
+            <a:ext cx="9692640" cy="1645920"/>
+          </a:xfrm>
+          <a:prstGeom prst="rect">
+            <a:avLst/>
+          </a:prstGeom>
+          <a:noFill/>
+          <a:ln/>
+        </p:spPr>
+        <p:txBody>
+          <a:bodyPr wrap="square" lIns="0" tIns="0" rIns="0" bIns="0" rtlCol="0" anchor="t"/>
+          <a:lstStyle/>
+          <a:p>
+            <a:pPr indent="0" marL="0">
+              <a:lnSpc>
+                <a:spcPct val="130000"/>
+              </a:lnSpc>
+              <a:buNone/>
+            </a:pPr>
+            <a:r>
+              <a:rPr lang="en-US" sz="1700" dirty="0">
+                <a:solidFill>
+                  <a:srgbClr val="FFFFFF"/>
+                </a:solidFill>
+                <a:effectLst>
+                  <a:outerShdw blurRad="165100" dist="0" dir="2700000" algn="ctr" rotWithShape="0">
+                    <a:srgbClr val="000000">
+                      <a:alpha val="96000"/>
+                    </a:srgbClr>
+                  </a:outerShdw>
+                </a:effectLst>
+                <a:latin typeface="Trebuchet MS" pitchFamily="34" charset="0"/>
+                <a:ea typeface="Trebuchet MS" pitchFamily="34" charset="-122"/>
+                <a:cs typeface="Trebuchet MS" pitchFamily="34" charset="-120"/>
+              </a:rPr>
+              <a:t>Two people review the same document and reach the same conclusion. One of them thought about it. The other agreed with it. No inspection anybody currently runs can tell them apart.</a:t>
+            </a:r>
+            <a:endParaRPr lang="en-US" sz="1700" dirty="0"/>
+          </a:p>
+        </p:txBody>
+      </p:sp>
       <p:sp>
         <p:nvSpPr>
           <p:cNvPr id="6" name="Text 3"/>
@@ -3117,8 +3228,15 @@
             <a:r>
               <a:rPr lang="en-US" sz="1150" dirty="0">
                 <a:solidFill>
-                  <a:srgbClr val="93A3B5"/>
-                </a:solidFill>
+                  <a:srgbClr val="FFFFFF"/>
+                </a:solidFill>
+                <a:effectLst>
+                  <a:outerShdw blurRad="165100" dist="0" dir="2700000" algn="ctr" rotWithShape="0">
+                    <a:srgbClr val="000000">
+                      <a:alpha val="96000"/>
+                    </a:srgbClr>
+                  </a:outerShdw>
+                </a:effectLst>
                 <a:latin typeface="Trebuchet MS" pitchFamily="34" charset="0"/>
                 <a:ea typeface="Trebuchet MS" pitchFamily="34" charset="-122"/>
                 <a:cs typeface="Trebuchet MS" pitchFamily="34" charset="-120"/>

</xml_diff>